<commit_message>
Editable PPTX: render card-grid layouts natively — hook spine as 3 graduated Past/Present/Future cards; section1 'paradigm shift' as two compare columns with arrow (was flattened to vertical text)
</commit_message>
<xml_diff>
--- a/keynote-iwbi-2026/pptx/IWBI2026_Trivedi_FULL_keynote.pptx
+++ b/keynote-iwbi-2026/pptx/IWBI2026_Trivedi_FULL_keynote.pptx
@@ -9281,8 +9281,8 @@
         </p:nvSpPr>
         <p:spPr>
           <a:xfrm>
-            <a:off x="777240" y="2081275"/>
-            <a:ext cx="10607040" cy="591312"/>
+            <a:off x="777240" y="1234440"/>
+            <a:ext cx="10607040" cy="822960"/>
           </a:xfrm>
           <a:prstGeom prst="rect">
             <a:avLst/>
@@ -9297,14 +9297,14 @@
           <a:p>
             <a:pPr algn="l">
               <a:lnSpc>
-                <a:spcPct val="106000"/>
+                <a:spcPct val="105000"/>
               </a:lnSpc>
               <a:spcAft>
                 <a:spcPts val="400"/>
               </a:spcAft>
             </a:pPr>
             <a:r>
-              <a:rPr sz="3000" b="0">
+              <a:rPr sz="2600" b="0">
                 <a:solidFill>
                   <a:srgbClr val="ECEFF3"/>
                 </a:solidFill>
@@ -9313,7 +9313,7 @@
               <a:t>A paradigm </a:t>
             </a:r>
             <a:r>
-              <a:rPr sz="3000" b="0">
+              <a:rPr sz="2600" b="0">
                 <a:solidFill>
                   <a:srgbClr val="E7AC51"/>
                 </a:solidFill>
@@ -9326,84 +9326,230 @@
       </p:sp>
       <p:sp>
         <p:nvSpPr>
-          <p:cNvPr id="5" name="TextBox 4"/>
-          <p:cNvSpPr txBox="1"/>
-          <p:nvPr/>
-        </p:nvSpPr>
-        <p:spPr>
-          <a:xfrm>
-            <a:off x="777240" y="2672587"/>
-            <a:ext cx="10607040" cy="346456"/>
-          </a:xfrm>
-          <a:prstGeom prst="rect">
-            <a:avLst/>
-          </a:prstGeom>
-          <a:noFill/>
-        </p:spPr>
-        <p:txBody>
-          <a:bodyPr wrap="square" lIns="25400" rIns="25400" tIns="12700" bIns="12700">
-            <a:noAutofit/>
-          </a:bodyPr>
+          <p:cNvPr id="5" name="Rounded Rectangle 4"/>
+          <p:cNvSpPr/>
+          <p:nvPr/>
+        </p:nvSpPr>
+        <p:spPr>
+          <a:xfrm>
+            <a:off x="777240" y="2468880"/>
+            <a:ext cx="4937760" cy="3291840"/>
+          </a:xfrm>
+          <a:prstGeom prst="roundRect">
+            <a:avLst/>
+          </a:prstGeom>
+          <a:solidFill>
+            <a:srgbClr val="1B232D"/>
+          </a:solidFill>
+          <a:ln w="12700">
+            <a:solidFill>
+              <a:srgbClr val="2A333E"/>
+            </a:solidFill>
+          </a:ln>
+          <a:effectLst/>
+        </p:spPr>
+        <p:style>
+          <a:lnRef idx="1">
+            <a:schemeClr val="accent1"/>
+          </a:lnRef>
+          <a:fillRef idx="3">
+            <a:schemeClr val="accent1"/>
+          </a:fillRef>
+          <a:effectRef idx="2">
+            <a:schemeClr val="accent1"/>
+          </a:effectRef>
+          <a:fontRef idx="minor">
+            <a:schemeClr val="lt1"/>
+          </a:fontRef>
+        </p:style>
+        <p:txBody>
+          <a:bodyPr rtlCol="0" anchor="t" wrap="square" lIns="274320" rIns="237744" tIns="256032" bIns="182880"/>
           <a:lstStyle/>
           <a:p>
             <a:pPr algn="l">
               <a:lnSpc>
-                <a:spcPct val="128000"/>
+                <a:spcPct val="100000"/>
               </a:lnSpc>
-              <a:spcAft>
-                <a:spcPts val="400"/>
-              </a:spcAft>
             </a:pPr>
             <a:r>
-              <a:rPr sz="1400" b="0">
-                <a:solidFill>
-                  <a:srgbClr val="9DA9B5"/>
-                </a:solidFill>
-                <a:latin typeface="Arial"/>
-              </a:rPr>
-              <a:t>Traditional CAD</a:t>
-            </a:r>
-          </a:p>
-        </p:txBody>
-      </p:sp>
-      <p:sp>
-        <p:nvSpPr>
-          <p:cNvPr id="6" name="TextBox 5"/>
-          <p:cNvSpPr txBox="1"/>
-          <p:nvPr/>
-        </p:nvSpPr>
-        <p:spPr>
-          <a:xfrm>
-            <a:off x="777240" y="3019043"/>
-            <a:ext cx="10607040" cy="346456"/>
-          </a:xfrm>
-          <a:prstGeom prst="rect">
-            <a:avLst/>
-          </a:prstGeom>
-          <a:noFill/>
-        </p:spPr>
-        <p:txBody>
-          <a:bodyPr wrap="square" lIns="25400" rIns="25400" tIns="12700" bIns="12700">
-            <a:noAutofit/>
-          </a:bodyPr>
-          <a:lstStyle/>
+              <a:rPr sz="1100" b="1">
+                <a:solidFill>
+                  <a:srgbClr val="5C6975"/>
+                </a:solidFill>
+                <a:latin typeface="Consolas"/>
+              </a:rPr>
+              <a:t>TRADITIONAL CAD</a:t>
+            </a:r>
+          </a:p>
           <a:p>
             <a:pPr algn="l">
               <a:lnSpc>
-                <a:spcPct val="128000"/>
+                <a:spcPct val="100000"/>
               </a:lnSpc>
-              <a:spcAft>
-                <a:spcPts val="400"/>
-              </a:spcAft>
+              <a:spcBef>
+                <a:spcPts val="800"/>
+              </a:spcBef>
             </a:pPr>
             <a:r>
-              <a:rPr sz="1400" b="0">
+              <a:rPr sz="2400" b="1">
                 <a:solidFill>
                   <a:srgbClr val="9DA9B5"/>
                 </a:solidFill>
                 <a:latin typeface="Arial"/>
               </a:rPr>
               <a:t>Programmed</a:t>
+            </a:r>
+          </a:p>
+          <a:p>
+            <a:pPr algn="l">
+              <a:lnSpc>
+                <a:spcPct val="130000"/>
+              </a:lnSpc>
+              <a:spcBef>
+                <a:spcPts val="800"/>
+              </a:spcBef>
+            </a:pPr>
+            <a:r>
+              <a:rPr sz="1300" b="0">
+                <a:solidFill>
+                  <a:srgbClr val="9DA9B5"/>
+                </a:solidFill>
+                <a:latin typeface="Arial"/>
+              </a:rPr>
+              <a:t>We wrote the rules for what cancer looks like. It </a:t>
+            </a:r>
+            <a:r>
+              <a:rPr sz="1300" b="0">
+                <a:solidFill>
+                  <a:srgbClr val="9DA9B5"/>
+                </a:solidFill>
+                <a:latin typeface="Arial"/>
+              </a:rPr>
+              <a:t>pointed</a:t>
+            </a:r>
+            <a:r>
+              <a:rPr sz="1300" b="0">
+                <a:solidFill>
+                  <a:srgbClr val="9DA9B5"/>
+                </a:solidFill>
+                <a:latin typeface="Arial"/>
+              </a:rPr>
+              <a:t> at spots for a human to check.</a:t>
+            </a:r>
+          </a:p>
+        </p:txBody>
+      </p:sp>
+      <p:sp>
+        <p:nvSpPr>
+          <p:cNvPr id="6" name="Rounded Rectangle 5"/>
+          <p:cNvSpPr/>
+          <p:nvPr/>
+        </p:nvSpPr>
+        <p:spPr>
+          <a:xfrm>
+            <a:off x="6446520" y="2468880"/>
+            <a:ext cx="4937760" cy="3291840"/>
+          </a:xfrm>
+          <a:prstGeom prst="roundRect">
+            <a:avLst/>
+          </a:prstGeom>
+          <a:solidFill>
+            <a:srgbClr val="1B232D"/>
+          </a:solidFill>
+          <a:ln w="15875">
+            <a:solidFill>
+              <a:srgbClr val="C98A2E"/>
+            </a:solidFill>
+          </a:ln>
+          <a:effectLst/>
+        </p:spPr>
+        <p:style>
+          <a:lnRef idx="1">
+            <a:schemeClr val="accent1"/>
+          </a:lnRef>
+          <a:fillRef idx="3">
+            <a:schemeClr val="accent1"/>
+          </a:fillRef>
+          <a:effectRef idx="2">
+            <a:schemeClr val="accent1"/>
+          </a:effectRef>
+          <a:fontRef idx="minor">
+            <a:schemeClr val="lt1"/>
+          </a:fontRef>
+        </p:style>
+        <p:txBody>
+          <a:bodyPr rtlCol="0" anchor="t" wrap="square" lIns="274320" rIns="237744" tIns="256032" bIns="182880"/>
+          <a:lstStyle/>
+          <a:p>
+            <a:pPr algn="l">
+              <a:lnSpc>
+                <a:spcPct val="100000"/>
+              </a:lnSpc>
+            </a:pPr>
+            <a:r>
+              <a:rPr sz="1100" b="1">
+                <a:solidFill>
+                  <a:srgbClr val="E7AC51"/>
+                </a:solidFill>
+                <a:latin typeface="Consolas"/>
+              </a:rPr>
+              <a:t>MODERN DEEP LEARNING</a:t>
+            </a:r>
+          </a:p>
+          <a:p>
+            <a:pPr algn="l">
+              <a:lnSpc>
+                <a:spcPct val="100000"/>
+              </a:lnSpc>
+              <a:spcBef>
+                <a:spcPts val="800"/>
+              </a:spcBef>
+            </a:pPr>
+            <a:r>
+              <a:rPr sz="2400" b="1">
+                <a:solidFill>
+                  <a:srgbClr val="ECEFF3"/>
+                </a:solidFill>
+                <a:latin typeface="Arial"/>
+              </a:rPr>
+              <a:t>Trained</a:t>
+            </a:r>
+          </a:p>
+          <a:p>
+            <a:pPr algn="l">
+              <a:lnSpc>
+                <a:spcPct val="130000"/>
+              </a:lnSpc>
+              <a:spcBef>
+                <a:spcPts val="800"/>
+              </a:spcBef>
+            </a:pPr>
+            <a:r>
+              <a:rPr sz="1300" b="0">
+                <a:solidFill>
+                  <a:srgbClr val="9DA9B5"/>
+                </a:solidFill>
+                <a:latin typeface="Arial"/>
+              </a:rPr>
+              <a:t>The model learns the patterns from the images themselves. It can </a:t>
+            </a:r>
+            <a:r>
+              <a:rPr sz="1300" b="0">
+                <a:solidFill>
+                  <a:srgbClr val="9DA9B5"/>
+                </a:solidFill>
+                <a:latin typeface="Arial"/>
+              </a:rPr>
+              <a:t>read</a:t>
+            </a:r>
+            <a:r>
+              <a:rPr sz="1300" b="0">
+                <a:solidFill>
+                  <a:srgbClr val="9DA9B5"/>
+                </a:solidFill>
+                <a:latin typeface="Arial"/>
+              </a:rPr>
+              <a:t> the image — as a second reader, or on its own.</a:t>
             </a:r>
           </a:p>
         </p:txBody>
@@ -9416,8 +9562,8 @@
         </p:nvSpPr>
         <p:spPr>
           <a:xfrm>
-            <a:off x="777240" y="3365500"/>
-            <a:ext cx="10607040" cy="346456"/>
+            <a:off x="5715000" y="3794760"/>
+            <a:ext cx="731520" cy="640080"/>
           </a:xfrm>
           <a:prstGeom prst="rect">
             <a:avLst/>
@@ -9425,231 +9571,20 @@
           <a:noFill/>
         </p:spPr>
         <p:txBody>
-          <a:bodyPr wrap="square" lIns="25400" rIns="25400" tIns="12700" bIns="12700">
-            <a:noAutofit/>
+          <a:bodyPr wrap="none" anchor="ctr">
+            <a:spAutoFit/>
           </a:bodyPr>
           <a:lstStyle/>
           <a:p>
-            <a:pPr algn="l">
-              <a:lnSpc>
-                <a:spcPct val="128000"/>
-              </a:lnSpc>
-              <a:spcAft>
-                <a:spcPts val="400"/>
-              </a:spcAft>
-            </a:pPr>
-            <a:r>
-              <a:rPr sz="1400" b="0">
-                <a:solidFill>
-                  <a:srgbClr val="9DA9B5"/>
-                </a:solidFill>
-                <a:latin typeface="Arial"/>
-              </a:rPr>
-              <a:t>We wrote the rules for what cancer looks like. It </a:t>
-            </a:r>
-            <a:r>
-              <a:rPr sz="1400" b="0">
-                <a:solidFill>
-                  <a:srgbClr val="9DA9B5"/>
-                </a:solidFill>
-                <a:latin typeface="Arial"/>
-              </a:rPr>
-              <a:t>pointed</a:t>
-            </a:r>
-            <a:r>
-              <a:rPr sz="1400" b="0">
-                <a:solidFill>
-                  <a:srgbClr val="9DA9B5"/>
-                </a:solidFill>
-                <a:latin typeface="Arial"/>
-              </a:rPr>
-              <a:t> at spots for a human to check.</a:t>
-            </a:r>
-          </a:p>
-        </p:txBody>
-      </p:sp>
-      <p:sp>
-        <p:nvSpPr>
-          <p:cNvPr id="8" name="TextBox 7"/>
-          <p:cNvSpPr txBox="1"/>
-          <p:nvPr/>
-        </p:nvSpPr>
-        <p:spPr>
-          <a:xfrm>
-            <a:off x="777240" y="3711955"/>
-            <a:ext cx="10607040" cy="346456"/>
-          </a:xfrm>
-          <a:prstGeom prst="rect">
-            <a:avLst/>
-          </a:prstGeom>
-          <a:noFill/>
-        </p:spPr>
-        <p:txBody>
-          <a:bodyPr wrap="square" lIns="25400" rIns="25400" tIns="12700" bIns="12700">
-            <a:noAutofit/>
-          </a:bodyPr>
-          <a:lstStyle/>
-          <a:p>
-            <a:pPr algn="l">
-              <a:lnSpc>
-                <a:spcPct val="128000"/>
-              </a:lnSpc>
-              <a:spcAft>
-                <a:spcPts val="400"/>
-              </a:spcAft>
-            </a:pPr>
-            <a:r>
-              <a:rPr sz="1400" b="0">
-                <a:solidFill>
-                  <a:srgbClr val="9DA9B5"/>
+            <a:pPr algn="ctr"/>
+            <a:r>
+              <a:rPr sz="2800">
+                <a:solidFill>
+                  <a:srgbClr val="E7AC51"/>
                 </a:solidFill>
                 <a:latin typeface="Arial"/>
               </a:rPr>
               <a:t>→</a:t>
-            </a:r>
-          </a:p>
-        </p:txBody>
-      </p:sp>
-      <p:sp>
-        <p:nvSpPr>
-          <p:cNvPr id="9" name="TextBox 8"/>
-          <p:cNvSpPr txBox="1"/>
-          <p:nvPr/>
-        </p:nvSpPr>
-        <p:spPr>
-          <a:xfrm>
-            <a:off x="777240" y="4058411"/>
-            <a:ext cx="10607040" cy="346456"/>
-          </a:xfrm>
-          <a:prstGeom prst="rect">
-            <a:avLst/>
-          </a:prstGeom>
-          <a:noFill/>
-        </p:spPr>
-        <p:txBody>
-          <a:bodyPr wrap="square" lIns="25400" rIns="25400" tIns="12700" bIns="12700">
-            <a:noAutofit/>
-          </a:bodyPr>
-          <a:lstStyle/>
-          <a:p>
-            <a:pPr algn="l">
-              <a:lnSpc>
-                <a:spcPct val="128000"/>
-              </a:lnSpc>
-              <a:spcAft>
-                <a:spcPts val="400"/>
-              </a:spcAft>
-            </a:pPr>
-            <a:r>
-              <a:rPr sz="1400" b="0">
-                <a:solidFill>
-                  <a:srgbClr val="9DA9B5"/>
-                </a:solidFill>
-                <a:latin typeface="Arial"/>
-              </a:rPr>
-              <a:t>Modern deep learning</a:t>
-            </a:r>
-          </a:p>
-        </p:txBody>
-      </p:sp>
-      <p:sp>
-        <p:nvSpPr>
-          <p:cNvPr id="10" name="TextBox 9"/>
-          <p:cNvSpPr txBox="1"/>
-          <p:nvPr/>
-        </p:nvSpPr>
-        <p:spPr>
-          <a:xfrm>
-            <a:off x="777240" y="4404867"/>
-            <a:ext cx="10607040" cy="346456"/>
-          </a:xfrm>
-          <a:prstGeom prst="rect">
-            <a:avLst/>
-          </a:prstGeom>
-          <a:noFill/>
-        </p:spPr>
-        <p:txBody>
-          <a:bodyPr wrap="square" lIns="25400" rIns="25400" tIns="12700" bIns="12700">
-            <a:noAutofit/>
-          </a:bodyPr>
-          <a:lstStyle/>
-          <a:p>
-            <a:pPr algn="l">
-              <a:lnSpc>
-                <a:spcPct val="128000"/>
-              </a:lnSpc>
-              <a:spcAft>
-                <a:spcPts val="400"/>
-              </a:spcAft>
-            </a:pPr>
-            <a:r>
-              <a:rPr sz="1400" b="0">
-                <a:solidFill>
-                  <a:srgbClr val="9DA9B5"/>
-                </a:solidFill>
-                <a:latin typeface="Arial"/>
-              </a:rPr>
-              <a:t>Trained</a:t>
-            </a:r>
-          </a:p>
-        </p:txBody>
-      </p:sp>
-      <p:sp>
-        <p:nvSpPr>
-          <p:cNvPr id="11" name="TextBox 10"/>
-          <p:cNvSpPr txBox="1"/>
-          <p:nvPr/>
-        </p:nvSpPr>
-        <p:spPr>
-          <a:xfrm>
-            <a:off x="777240" y="4751323"/>
-            <a:ext cx="10607040" cy="574040"/>
-          </a:xfrm>
-          <a:prstGeom prst="rect">
-            <a:avLst/>
-          </a:prstGeom>
-          <a:noFill/>
-        </p:spPr>
-        <p:txBody>
-          <a:bodyPr wrap="square" lIns="25400" rIns="25400" tIns="12700" bIns="12700">
-            <a:noAutofit/>
-          </a:bodyPr>
-          <a:lstStyle/>
-          <a:p>
-            <a:pPr algn="l">
-              <a:lnSpc>
-                <a:spcPct val="128000"/>
-              </a:lnSpc>
-              <a:spcAft>
-                <a:spcPts val="400"/>
-              </a:spcAft>
-            </a:pPr>
-            <a:r>
-              <a:rPr sz="1400" b="0">
-                <a:solidFill>
-                  <a:srgbClr val="9DA9B5"/>
-                </a:solidFill>
-                <a:latin typeface="Arial"/>
-              </a:rPr>
-              <a:t>The model learns the patterns from the images themselves. It can </a:t>
-            </a:r>
-            <a:r>
-              <a:rPr sz="1400" b="0">
-                <a:solidFill>
-                  <a:srgbClr val="9DA9B5"/>
-                </a:solidFill>
-                <a:latin typeface="Arial"/>
-              </a:rPr>
-              <a:t>read</a:t>
-            </a:r>
-            <a:r>
-              <a:rPr sz="1400" b="0">
-                <a:solidFill>
-                  <a:srgbClr val="9DA9B5"/>
-                </a:solidFill>
-                <a:latin typeface="Arial"/>
-              </a:rPr>
-              <a:t> the image — as a second reader, or on its own.</a:t>
             </a:r>
           </a:p>
         </p:txBody>
@@ -29764,8 +29699,8 @@
         </p:nvSpPr>
         <p:spPr>
           <a:xfrm>
-            <a:off x="777240" y="1265935"/>
-            <a:ext cx="10607040" cy="534416"/>
+            <a:off x="777240" y="1325880"/>
+            <a:ext cx="10607040" cy="914400"/>
           </a:xfrm>
           <a:prstGeom prst="rect">
             <a:avLst/>
@@ -29780,14 +29715,14 @@
           <a:p>
             <a:pPr algn="l">
               <a:lnSpc>
-                <a:spcPct val="106000"/>
+                <a:spcPct val="104000"/>
               </a:lnSpc>
               <a:spcAft>
                 <a:spcPts val="400"/>
               </a:spcAft>
             </a:pPr>
             <a:r>
-              <a:rPr sz="2600" b="0">
+              <a:rPr sz="4400" b="0">
                 <a:solidFill>
                   <a:srgbClr val="ECEFF3"/>
                 </a:solidFill>
@@ -29796,7 +29731,7 @@
               <a:t>From lesions to </a:t>
             </a:r>
             <a:r>
-              <a:rPr sz="2600" b="0">
+              <a:rPr sz="4400" b="0">
                 <a:solidFill>
                   <a:srgbClr val="E7AC51"/>
                 </a:solidFill>
@@ -29809,162 +29744,110 @@
       </p:sp>
       <p:sp>
         <p:nvSpPr>
-          <p:cNvPr id="4" name="TextBox 3"/>
-          <p:cNvSpPr txBox="1"/>
-          <p:nvPr/>
-        </p:nvSpPr>
-        <p:spPr>
-          <a:xfrm>
-            <a:off x="777240" y="1800351"/>
-            <a:ext cx="10607040" cy="346456"/>
-          </a:xfrm>
-          <a:prstGeom prst="rect">
-            <a:avLst/>
-          </a:prstGeom>
-          <a:noFill/>
-        </p:spPr>
-        <p:txBody>
-          <a:bodyPr wrap="square" lIns="25400" rIns="25400" tIns="12700" bIns="12700">
-            <a:noAutofit/>
-          </a:bodyPr>
+          <p:cNvPr id="4" name="Rounded Rectangle 3"/>
+          <p:cNvSpPr/>
+          <p:nvPr/>
+        </p:nvSpPr>
+        <p:spPr>
+          <a:xfrm>
+            <a:off x="777240" y="3063240"/>
+            <a:ext cx="3429000" cy="2286000"/>
+          </a:xfrm>
+          <a:prstGeom prst="roundRect">
+            <a:avLst/>
+          </a:prstGeom>
+          <a:solidFill>
+            <a:srgbClr val="1B232D"/>
+          </a:solidFill>
+          <a:ln w="15875">
+            <a:solidFill>
+              <a:srgbClr val="2A333E"/>
+            </a:solidFill>
+          </a:ln>
+          <a:effectLst/>
+        </p:spPr>
+        <p:style>
+          <a:lnRef idx="1">
+            <a:schemeClr val="accent1"/>
+          </a:lnRef>
+          <a:fillRef idx="3">
+            <a:schemeClr val="accent1"/>
+          </a:fillRef>
+          <a:effectRef idx="2">
+            <a:schemeClr val="accent1"/>
+          </a:effectRef>
+          <a:fontRef idx="minor">
+            <a:schemeClr val="lt1"/>
+          </a:fontRef>
+        </p:style>
+        <p:txBody>
+          <a:bodyPr rtlCol="0" anchor="t" wrap="square" lIns="256032" rIns="219456" tIns="384048" bIns="182880"/>
           <a:lstStyle/>
           <a:p>
             <a:pPr algn="l">
               <a:lnSpc>
-                <a:spcPct val="128000"/>
+                <a:spcPct val="100000"/>
               </a:lnSpc>
-              <a:spcAft>
-                <a:spcPts val="400"/>
-              </a:spcAft>
             </a:pPr>
             <a:r>
-              <a:rPr sz="1400" b="0">
-                <a:solidFill>
-                  <a:srgbClr val="9DA9B5"/>
-                </a:solidFill>
-                <a:latin typeface="Arial"/>
+              <a:rPr sz="1100" b="0">
+                <a:solidFill>
+                  <a:srgbClr val="5C6975"/>
+                </a:solidFill>
+                <a:latin typeface="Consolas"/>
               </a:rPr>
               <a:t>01</a:t>
             </a:r>
           </a:p>
-        </p:txBody>
-      </p:sp>
-      <p:sp>
-        <p:nvSpPr>
-          <p:cNvPr id="5" name="TextBox 4"/>
-          <p:cNvSpPr txBox="1"/>
-          <p:nvPr/>
-        </p:nvSpPr>
-        <p:spPr>
-          <a:xfrm>
-            <a:off x="777240" y="2146807"/>
-            <a:ext cx="10607040" cy="346456"/>
-          </a:xfrm>
-          <a:prstGeom prst="rect">
-            <a:avLst/>
-          </a:prstGeom>
-          <a:noFill/>
-        </p:spPr>
-        <p:txBody>
-          <a:bodyPr wrap="square" lIns="25400" rIns="25400" tIns="12700" bIns="12700">
-            <a:noAutofit/>
-          </a:bodyPr>
-          <a:lstStyle/>
           <a:p>
             <a:pPr algn="l">
               <a:lnSpc>
-                <a:spcPct val="128000"/>
+                <a:spcPct val="100000"/>
               </a:lnSpc>
-              <a:spcAft>
+              <a:spcBef>
                 <a:spcPts val="400"/>
-              </a:spcAft>
+              </a:spcBef>
             </a:pPr>
             <a:r>
-              <a:rPr sz="1400" b="0">
+              <a:rPr sz="1000" b="1">
                 <a:solidFill>
                   <a:srgbClr val="E7AC51"/>
                 </a:solidFill>
-                <a:latin typeface="Arial"/>
-              </a:rPr>
-              <a:t>Past</a:t>
-            </a:r>
-          </a:p>
-        </p:txBody>
-      </p:sp>
-      <p:sp>
-        <p:nvSpPr>
-          <p:cNvPr id="6" name="TextBox 5"/>
-          <p:cNvSpPr txBox="1"/>
-          <p:nvPr/>
-        </p:nvSpPr>
-        <p:spPr>
-          <a:xfrm>
-            <a:off x="777240" y="2493264"/>
-            <a:ext cx="10607040" cy="346456"/>
-          </a:xfrm>
-          <a:prstGeom prst="rect">
-            <a:avLst/>
-          </a:prstGeom>
-          <a:noFill/>
-        </p:spPr>
-        <p:txBody>
-          <a:bodyPr wrap="square" lIns="25400" rIns="25400" tIns="12700" bIns="12700">
-            <a:noAutofit/>
-          </a:bodyPr>
-          <a:lstStyle/>
+                <a:latin typeface="Consolas"/>
+              </a:rPr>
+              <a:t>PAST</a:t>
+            </a:r>
+          </a:p>
           <a:p>
             <a:pPr algn="l">
               <a:lnSpc>
-                <a:spcPct val="128000"/>
+                <a:spcPct val="100000"/>
               </a:lnSpc>
-              <a:spcAft>
-                <a:spcPts val="400"/>
-              </a:spcAft>
+              <a:spcBef>
+                <a:spcPts val="600"/>
+              </a:spcBef>
             </a:pPr>
             <a:r>
-              <a:rPr sz="1400" b="0">
-                <a:solidFill>
-                  <a:srgbClr val="9DA9B5"/>
+              <a:rPr sz="2600" b="1">
+                <a:solidFill>
+                  <a:srgbClr val="ECEFF3"/>
                 </a:solidFill>
                 <a:latin typeface="Arial"/>
               </a:rPr>
               <a:t>Lesion</a:t>
             </a:r>
           </a:p>
-        </p:txBody>
-      </p:sp>
-      <p:sp>
-        <p:nvSpPr>
-          <p:cNvPr id="7" name="TextBox 6"/>
-          <p:cNvSpPr txBox="1"/>
-          <p:nvPr/>
-        </p:nvSpPr>
-        <p:spPr>
-          <a:xfrm>
-            <a:off x="777240" y="2839720"/>
-            <a:ext cx="10607040" cy="346456"/>
-          </a:xfrm>
-          <a:prstGeom prst="rect">
-            <a:avLst/>
-          </a:prstGeom>
-          <a:noFill/>
-        </p:spPr>
-        <p:txBody>
-          <a:bodyPr wrap="square" lIns="25400" rIns="25400" tIns="12700" bIns="12700">
-            <a:noAutofit/>
-          </a:bodyPr>
-          <a:lstStyle/>
           <a:p>
             <a:pPr algn="l">
               <a:lnSpc>
-                <a:spcPct val="128000"/>
+                <a:spcPct val="125000"/>
               </a:lnSpc>
-              <a:spcAft>
-                <a:spcPts val="400"/>
-              </a:spcAft>
+              <a:spcBef>
+                <a:spcPts val="600"/>
+              </a:spcBef>
             </a:pPr>
             <a:r>
-              <a:rPr sz="1400" b="0">
+              <a:rPr sz="1250" b="0">
                 <a:solidFill>
                   <a:srgbClr val="9DA9B5"/>
                 </a:solidFill>
@@ -29977,162 +29860,154 @@
       </p:sp>
       <p:sp>
         <p:nvSpPr>
-          <p:cNvPr id="8" name="TextBox 7"/>
-          <p:cNvSpPr txBox="1"/>
-          <p:nvPr/>
-        </p:nvSpPr>
-        <p:spPr>
-          <a:xfrm>
-            <a:off x="777240" y="3186176"/>
-            <a:ext cx="10607040" cy="346456"/>
-          </a:xfrm>
-          <a:prstGeom prst="rect">
-            <a:avLst/>
-          </a:prstGeom>
-          <a:noFill/>
-        </p:spPr>
-        <p:txBody>
-          <a:bodyPr wrap="square" lIns="25400" rIns="25400" tIns="12700" bIns="12700">
-            <a:noAutofit/>
-          </a:bodyPr>
+          <p:cNvPr id="5" name="Rectangle 4"/>
+          <p:cNvSpPr/>
+          <p:nvPr/>
+        </p:nvSpPr>
+        <p:spPr>
+          <a:xfrm>
+            <a:off x="1005840" y="3264408"/>
+            <a:ext cx="411480" cy="31750"/>
+          </a:xfrm>
+          <a:prstGeom prst="rect">
+            <a:avLst/>
+          </a:prstGeom>
+          <a:solidFill>
+            <a:srgbClr val="E7AC51"/>
+          </a:solidFill>
+          <a:ln>
+            <a:noFill/>
+          </a:ln>
+          <a:effectLst/>
+        </p:spPr>
+        <p:style>
+          <a:lnRef idx="1">
+            <a:schemeClr val="accent1"/>
+          </a:lnRef>
+          <a:fillRef idx="3">
+            <a:schemeClr val="accent1"/>
+          </a:fillRef>
+          <a:effectRef idx="2">
+            <a:schemeClr val="accent1"/>
+          </a:effectRef>
+          <a:fontRef idx="minor">
+            <a:schemeClr val="lt1"/>
+          </a:fontRef>
+        </p:style>
+        <p:txBody>
+          <a:bodyPr rtlCol="0" anchor="ctr"/>
+          <a:lstStyle/>
+          <a:p>
+            <a:pPr algn="ctr"/>
+          </a:p>
+        </p:txBody>
+      </p:sp>
+      <p:sp>
+        <p:nvSpPr>
+          <p:cNvPr id="6" name="Rounded Rectangle 5"/>
+          <p:cNvSpPr/>
+          <p:nvPr/>
+        </p:nvSpPr>
+        <p:spPr>
+          <a:xfrm>
+            <a:off x="4457700" y="3063240"/>
+            <a:ext cx="3429000" cy="2286000"/>
+          </a:xfrm>
+          <a:prstGeom prst="roundRect">
+            <a:avLst/>
+          </a:prstGeom>
+          <a:solidFill>
+            <a:srgbClr val="3A2E16"/>
+          </a:solidFill>
+          <a:ln w="15875">
+            <a:solidFill>
+              <a:srgbClr val="C98A2E"/>
+            </a:solidFill>
+          </a:ln>
+          <a:effectLst/>
+        </p:spPr>
+        <p:style>
+          <a:lnRef idx="1">
+            <a:schemeClr val="accent1"/>
+          </a:lnRef>
+          <a:fillRef idx="3">
+            <a:schemeClr val="accent1"/>
+          </a:fillRef>
+          <a:effectRef idx="2">
+            <a:schemeClr val="accent1"/>
+          </a:effectRef>
+          <a:fontRef idx="minor">
+            <a:schemeClr val="lt1"/>
+          </a:fontRef>
+        </p:style>
+        <p:txBody>
+          <a:bodyPr rtlCol="0" anchor="t" wrap="square" lIns="256032" rIns="219456" tIns="384048" bIns="182880"/>
           <a:lstStyle/>
           <a:p>
             <a:pPr algn="l">
               <a:lnSpc>
-                <a:spcPct val="128000"/>
+                <a:spcPct val="100000"/>
               </a:lnSpc>
-              <a:spcAft>
-                <a:spcPts val="400"/>
-              </a:spcAft>
             </a:pPr>
             <a:r>
-              <a:rPr sz="1400" b="0">
-                <a:solidFill>
-                  <a:srgbClr val="9DA9B5"/>
-                </a:solidFill>
-                <a:latin typeface="Arial"/>
+              <a:rPr sz="1100" b="0">
+                <a:solidFill>
+                  <a:srgbClr val="5C6975"/>
+                </a:solidFill>
+                <a:latin typeface="Consolas"/>
               </a:rPr>
               <a:t>02</a:t>
             </a:r>
           </a:p>
-        </p:txBody>
-      </p:sp>
-      <p:sp>
-        <p:nvSpPr>
-          <p:cNvPr id="9" name="TextBox 8"/>
-          <p:cNvSpPr txBox="1"/>
-          <p:nvPr/>
-        </p:nvSpPr>
-        <p:spPr>
-          <a:xfrm>
-            <a:off x="777240" y="3532632"/>
-            <a:ext cx="10607040" cy="346456"/>
-          </a:xfrm>
-          <a:prstGeom prst="rect">
-            <a:avLst/>
-          </a:prstGeom>
-          <a:noFill/>
-        </p:spPr>
-        <p:txBody>
-          <a:bodyPr wrap="square" lIns="25400" rIns="25400" tIns="12700" bIns="12700">
-            <a:noAutofit/>
-          </a:bodyPr>
-          <a:lstStyle/>
           <a:p>
             <a:pPr algn="l">
               <a:lnSpc>
-                <a:spcPct val="128000"/>
+                <a:spcPct val="100000"/>
               </a:lnSpc>
-              <a:spcAft>
+              <a:spcBef>
                 <a:spcPts val="400"/>
-              </a:spcAft>
+              </a:spcBef>
             </a:pPr>
             <a:r>
-              <a:rPr sz="1400" b="0">
+              <a:rPr sz="1000" b="1">
                 <a:solidFill>
                   <a:srgbClr val="E7AC51"/>
                 </a:solidFill>
-                <a:latin typeface="Arial"/>
-              </a:rPr>
-              <a:t>Present</a:t>
-            </a:r>
-          </a:p>
-        </p:txBody>
-      </p:sp>
-      <p:sp>
-        <p:nvSpPr>
-          <p:cNvPr id="10" name="TextBox 9"/>
-          <p:cNvSpPr txBox="1"/>
-          <p:nvPr/>
-        </p:nvSpPr>
-        <p:spPr>
-          <a:xfrm>
-            <a:off x="777240" y="3879088"/>
-            <a:ext cx="10607040" cy="346456"/>
-          </a:xfrm>
-          <a:prstGeom prst="rect">
-            <a:avLst/>
-          </a:prstGeom>
-          <a:noFill/>
-        </p:spPr>
-        <p:txBody>
-          <a:bodyPr wrap="square" lIns="25400" rIns="25400" tIns="12700" bIns="12700">
-            <a:noAutofit/>
-          </a:bodyPr>
-          <a:lstStyle/>
+                <a:latin typeface="Consolas"/>
+              </a:rPr>
+              <a:t>PRESENT</a:t>
+            </a:r>
+          </a:p>
           <a:p>
             <a:pPr algn="l">
               <a:lnSpc>
-                <a:spcPct val="128000"/>
+                <a:spcPct val="100000"/>
               </a:lnSpc>
-              <a:spcAft>
-                <a:spcPts val="400"/>
-              </a:spcAft>
+              <a:spcBef>
+                <a:spcPts val="600"/>
+              </a:spcBef>
             </a:pPr>
             <a:r>
-              <a:rPr sz="1400" b="0">
-                <a:solidFill>
-                  <a:srgbClr val="9DA9B5"/>
+              <a:rPr sz="2600" b="1">
+                <a:solidFill>
+                  <a:srgbClr val="ECEFF3"/>
                 </a:solidFill>
                 <a:latin typeface="Arial"/>
               </a:rPr>
               <a:t>Image</a:t>
             </a:r>
           </a:p>
-        </p:txBody>
-      </p:sp>
-      <p:sp>
-        <p:nvSpPr>
-          <p:cNvPr id="11" name="TextBox 10"/>
-          <p:cNvSpPr txBox="1"/>
-          <p:nvPr/>
-        </p:nvSpPr>
-        <p:spPr>
-          <a:xfrm>
-            <a:off x="777240" y="4225544"/>
-            <a:ext cx="10607040" cy="346456"/>
-          </a:xfrm>
-          <a:prstGeom prst="rect">
-            <a:avLst/>
-          </a:prstGeom>
-          <a:noFill/>
-        </p:spPr>
-        <p:txBody>
-          <a:bodyPr wrap="square" lIns="25400" rIns="25400" tIns="12700" bIns="12700">
-            <a:noAutofit/>
-          </a:bodyPr>
-          <a:lstStyle/>
           <a:p>
             <a:pPr algn="l">
               <a:lnSpc>
-                <a:spcPct val="128000"/>
+                <a:spcPct val="125000"/>
               </a:lnSpc>
-              <a:spcAft>
-                <a:spcPts val="400"/>
-              </a:spcAft>
+              <a:spcBef>
+                <a:spcPts val="600"/>
+              </a:spcBef>
             </a:pPr>
             <a:r>
-              <a:rPr sz="1400" b="0">
+              <a:rPr sz="1250" b="0">
                 <a:solidFill>
                   <a:srgbClr val="9DA9B5"/>
                 </a:solidFill>
@@ -30145,169 +30020,205 @@
       </p:sp>
       <p:sp>
         <p:nvSpPr>
-          <p:cNvPr id="12" name="TextBox 11"/>
-          <p:cNvSpPr txBox="1"/>
-          <p:nvPr/>
-        </p:nvSpPr>
-        <p:spPr>
-          <a:xfrm>
-            <a:off x="777240" y="4572000"/>
-            <a:ext cx="10607040" cy="346456"/>
-          </a:xfrm>
-          <a:prstGeom prst="rect">
-            <a:avLst/>
-          </a:prstGeom>
-          <a:noFill/>
-        </p:spPr>
-        <p:txBody>
-          <a:bodyPr wrap="square" lIns="25400" rIns="25400" tIns="12700" bIns="12700">
-            <a:noAutofit/>
-          </a:bodyPr>
+          <p:cNvPr id="7" name="Rectangle 6"/>
+          <p:cNvSpPr/>
+          <p:nvPr/>
+        </p:nvSpPr>
+        <p:spPr>
+          <a:xfrm>
+            <a:off x="4686300" y="3264408"/>
+            <a:ext cx="411480" cy="31750"/>
+          </a:xfrm>
+          <a:prstGeom prst="rect">
+            <a:avLst/>
+          </a:prstGeom>
+          <a:solidFill>
+            <a:srgbClr val="E7AC51"/>
+          </a:solidFill>
+          <a:ln>
+            <a:noFill/>
+          </a:ln>
+          <a:effectLst/>
+        </p:spPr>
+        <p:style>
+          <a:lnRef idx="1">
+            <a:schemeClr val="accent1"/>
+          </a:lnRef>
+          <a:fillRef idx="3">
+            <a:schemeClr val="accent1"/>
+          </a:fillRef>
+          <a:effectRef idx="2">
+            <a:schemeClr val="accent1"/>
+          </a:effectRef>
+          <a:fontRef idx="minor">
+            <a:schemeClr val="lt1"/>
+          </a:fontRef>
+        </p:style>
+        <p:txBody>
+          <a:bodyPr rtlCol="0" anchor="ctr"/>
+          <a:lstStyle/>
+          <a:p>
+            <a:pPr algn="ctr"/>
+          </a:p>
+        </p:txBody>
+      </p:sp>
+      <p:sp>
+        <p:nvSpPr>
+          <p:cNvPr id="8" name="Rounded Rectangle 7"/>
+          <p:cNvSpPr/>
+          <p:nvPr/>
+        </p:nvSpPr>
+        <p:spPr>
+          <a:xfrm>
+            <a:off x="8138160" y="3063240"/>
+            <a:ext cx="3429000" cy="2286000"/>
+          </a:xfrm>
+          <a:prstGeom prst="roundRect">
+            <a:avLst/>
+          </a:prstGeom>
+          <a:solidFill>
+            <a:srgbClr val="E7AC51"/>
+          </a:solidFill>
+          <a:ln w="15875">
+            <a:solidFill>
+              <a:srgbClr val="C98A2E"/>
+            </a:solidFill>
+          </a:ln>
+          <a:effectLst/>
+        </p:spPr>
+        <p:style>
+          <a:lnRef idx="1">
+            <a:schemeClr val="accent1"/>
+          </a:lnRef>
+          <a:fillRef idx="3">
+            <a:schemeClr val="accent1"/>
+          </a:fillRef>
+          <a:effectRef idx="2">
+            <a:schemeClr val="accent1"/>
+          </a:effectRef>
+          <a:fontRef idx="minor">
+            <a:schemeClr val="lt1"/>
+          </a:fontRef>
+        </p:style>
+        <p:txBody>
+          <a:bodyPr rtlCol="0" anchor="t" wrap="square" lIns="256032" rIns="219456" tIns="384048" bIns="182880"/>
           <a:lstStyle/>
           <a:p>
             <a:pPr algn="l">
               <a:lnSpc>
-                <a:spcPct val="128000"/>
+                <a:spcPct val="100000"/>
               </a:lnSpc>
-              <a:spcAft>
-                <a:spcPts val="400"/>
-              </a:spcAft>
             </a:pPr>
             <a:r>
-              <a:rPr sz="1400" b="0">
-                <a:solidFill>
-                  <a:srgbClr val="9DA9B5"/>
-                </a:solidFill>
-                <a:latin typeface="Arial"/>
+              <a:rPr sz="1100" b="0">
+                <a:solidFill>
+                  <a:srgbClr val="403014"/>
+                </a:solidFill>
+                <a:latin typeface="Consolas"/>
               </a:rPr>
               <a:t>03</a:t>
             </a:r>
           </a:p>
-        </p:txBody>
-      </p:sp>
-      <p:sp>
-        <p:nvSpPr>
-          <p:cNvPr id="13" name="TextBox 12"/>
-          <p:cNvSpPr txBox="1"/>
-          <p:nvPr/>
-        </p:nvSpPr>
-        <p:spPr>
-          <a:xfrm>
-            <a:off x="777240" y="4918456"/>
-            <a:ext cx="10607040" cy="346456"/>
-          </a:xfrm>
-          <a:prstGeom prst="rect">
-            <a:avLst/>
-          </a:prstGeom>
-          <a:noFill/>
-        </p:spPr>
-        <p:txBody>
-          <a:bodyPr wrap="square" lIns="25400" rIns="25400" tIns="12700" bIns="12700">
-            <a:noAutofit/>
-          </a:bodyPr>
-          <a:lstStyle/>
           <a:p>
             <a:pPr algn="l">
               <a:lnSpc>
-                <a:spcPct val="128000"/>
+                <a:spcPct val="100000"/>
               </a:lnSpc>
-              <a:spcAft>
+              <a:spcBef>
                 <a:spcPts val="400"/>
-              </a:spcAft>
+              </a:spcBef>
             </a:pPr>
             <a:r>
-              <a:rPr sz="1400" b="0">
-                <a:solidFill>
-                  <a:srgbClr val="E7AC51"/>
-                </a:solidFill>
-                <a:latin typeface="Arial"/>
-              </a:rPr>
-              <a:t>Future</a:t>
-            </a:r>
-          </a:p>
-        </p:txBody>
-      </p:sp>
-      <p:sp>
-        <p:nvSpPr>
-          <p:cNvPr id="14" name="TextBox 13"/>
-          <p:cNvSpPr txBox="1"/>
-          <p:nvPr/>
-        </p:nvSpPr>
-        <p:spPr>
-          <a:xfrm>
-            <a:off x="777240" y="5264911"/>
-            <a:ext cx="10607040" cy="346456"/>
-          </a:xfrm>
-          <a:prstGeom prst="rect">
-            <a:avLst/>
-          </a:prstGeom>
-          <a:noFill/>
-        </p:spPr>
-        <p:txBody>
-          <a:bodyPr wrap="square" lIns="25400" rIns="25400" tIns="12700" bIns="12700">
-            <a:noAutofit/>
-          </a:bodyPr>
-          <a:lstStyle/>
+              <a:rPr sz="1000" b="1">
+                <a:solidFill>
+                  <a:srgbClr val="1A1206"/>
+                </a:solidFill>
+                <a:latin typeface="Consolas"/>
+              </a:rPr>
+              <a:t>FUTURE</a:t>
+            </a:r>
+          </a:p>
           <a:p>
             <a:pPr algn="l">
               <a:lnSpc>
-                <a:spcPct val="128000"/>
+                <a:spcPct val="100000"/>
               </a:lnSpc>
-              <a:spcAft>
-                <a:spcPts val="400"/>
-              </a:spcAft>
+              <a:spcBef>
+                <a:spcPts val="600"/>
+              </a:spcBef>
             </a:pPr>
             <a:r>
-              <a:rPr sz="1400" b="0">
-                <a:solidFill>
-                  <a:srgbClr val="9DA9B5"/>
+              <a:rPr sz="2600" b="1">
+                <a:solidFill>
+                  <a:srgbClr val="1A1206"/>
                 </a:solidFill>
                 <a:latin typeface="Arial"/>
               </a:rPr>
               <a:t>Patient</a:t>
             </a:r>
           </a:p>
-        </p:txBody>
-      </p:sp>
-      <p:sp>
-        <p:nvSpPr>
-          <p:cNvPr id="15" name="TextBox 14"/>
-          <p:cNvSpPr txBox="1"/>
-          <p:nvPr/>
-        </p:nvSpPr>
-        <p:spPr>
-          <a:xfrm>
-            <a:off x="777240" y="5611367"/>
-            <a:ext cx="10607040" cy="346456"/>
-          </a:xfrm>
-          <a:prstGeom prst="rect">
-            <a:avLst/>
-          </a:prstGeom>
-          <a:noFill/>
-        </p:spPr>
-        <p:txBody>
-          <a:bodyPr wrap="square" lIns="25400" rIns="25400" tIns="12700" bIns="12700">
-            <a:noAutofit/>
-          </a:bodyPr>
-          <a:lstStyle/>
           <a:p>
             <a:pPr algn="l">
               <a:lnSpc>
-                <a:spcPct val="128000"/>
+                <a:spcPct val="125000"/>
               </a:lnSpc>
-              <a:spcAft>
-                <a:spcPts val="400"/>
-              </a:spcAft>
+              <a:spcBef>
+                <a:spcPts val="600"/>
+              </a:spcBef>
             </a:pPr>
             <a:r>
-              <a:rPr sz="1400" b="0">
-                <a:solidFill>
-                  <a:srgbClr val="9DA9B5"/>
+              <a:rPr sz="1250" b="0">
+                <a:solidFill>
+                  <a:srgbClr val="2A1E0A"/>
                 </a:solidFill>
                 <a:latin typeface="Arial"/>
               </a:rPr>
               <a:t>pathology + integration</a:t>
             </a:r>
+          </a:p>
+        </p:txBody>
+      </p:sp>
+      <p:sp>
+        <p:nvSpPr>
+          <p:cNvPr id="9" name="Rectangle 8"/>
+          <p:cNvSpPr/>
+          <p:nvPr/>
+        </p:nvSpPr>
+        <p:spPr>
+          <a:xfrm>
+            <a:off x="8366760" y="3264408"/>
+            <a:ext cx="411480" cy="31750"/>
+          </a:xfrm>
+          <a:prstGeom prst="rect">
+            <a:avLst/>
+          </a:prstGeom>
+          <a:solidFill>
+            <a:srgbClr val="1A1206"/>
+          </a:solidFill>
+          <a:ln>
+            <a:noFill/>
+          </a:ln>
+          <a:effectLst/>
+        </p:spPr>
+        <p:style>
+          <a:lnRef idx="1">
+            <a:schemeClr val="accent1"/>
+          </a:lnRef>
+          <a:fillRef idx="3">
+            <a:schemeClr val="accent1"/>
+          </a:fillRef>
+          <a:effectRef idx="2">
+            <a:schemeClr val="accent1"/>
+          </a:effectRef>
+          <a:fontRef idx="minor">
+            <a:schemeClr val="lt1"/>
+          </a:fontRef>
+        </p:style>
+        <p:txBody>
+          <a:bodyPr rtlCol="0" anchor="ctr"/>
+          <a:lstStyle/>
+          <a:p>
+            <a:pPr algn="ctr"/>
           </a:p>
         </p:txBody>
       </p:sp>

</xml_diff>